<commit_message>
Unidade 1 de Estado, Governo e Mercado: slides com os exemplos de custo de oportunidade, oferta e demanda (estacionamento rotativo) e elasticidade (tarifa de água)
Co-Authored-By: Claude Opus 5.5 <noreply@anthropic.com>
Claude-Session: https://claude.ai/code/session_01PyQDDPKwUxu1Vg7o8uyr7W
</commit_message>
<xml_diff>
--- a/disciplina-01-estado-governo-mercado/materiais/04_Unidade_4_Modelos_de_Estado_e_Brasil.pptx
+++ b/disciplina-01-estado-governo-mercado/materiais/04_Unidade_4_Modelos_de_Estado_e_Brasil.pptx
@@ -142,511 +142,7 @@
 </p:presentation>
 </file>
 
-<file path=ppt/charts/chart6.xml><?xml version="1.0" encoding="utf-8"?>
-<c:chartSpace xmlns:c="http://schemas.openxmlformats.org/drawingml/2006/chart" xmlns:a="http://schemas.openxmlformats.org/drawingml/2006/main" xmlns:r="http://schemas.openxmlformats.org/officeDocument/2006/relationships">
-  <c:date1904 val="0"/>
-  <c:roundedCorners val="1"/>
-  <c:chart>
-    <c:autoTitleDeleted val="1"/>
-    <c:plotArea>
-      <c:layout/>
-      <c:barChart>
-        <c:barDir val="col"/>
-        <c:grouping val="clustered"/>
-        <c:varyColors val="0"/>
-        <c:ser>
-          <c:idx val="0"/>
-          <c:order val="0"/>
-          <c:tx>
-            <c:strRef>
-              <c:f>Sheet1!$B$1</c:f>
-              <c:strCache>
-                <c:ptCount val="1"/>
-                <c:pt idx="0">
-                  <c:v>Renda</c:v>
-                </c:pt>
-              </c:strCache>
-            </c:strRef>
-          </c:tx>
-          <c:spPr>
-            <a:solidFill>
-              <a:srgbClr val="13294B"/>
-            </a:solidFill>
-            <a:effectLst/>
-          </c:spPr>
-          <c:invertIfNegative val="0"/>
-          <c:dLbls>
-            <c:numFmt formatCode="0" sourceLinked="0"/>
-            <c:txPr>
-              <a:bodyPr/>
-              <a:lstStyle/>
-              <a:p>
-                <a:pPr>
-                  <a:defRPr b="0" i="0" strike="noStrike" sz="1050" u="none">
-                    <a:solidFill>
-                      <a:srgbClr val="1F2A37"/>
-                    </a:solidFill>
-                    <a:latin typeface="Calibri"/>
-                  </a:defRPr>
-                </a:pPr>
-              </a:p>
-            </c:txPr>
-            <c:showLegendKey val="0"/>
-            <c:showVal val="1"/>
-            <c:showCatName val="0"/>
-            <c:showSerName val="0"/>
-            <c:showPercent val="0"/>
-            <c:showBubbleSize val="0"/>
-            <c:showLeaderLines val="0"/>
-          </c:dLbls>
-          <c:cat>
-            <c:multiLvlStrRef>
-              <c:f>Sheet1!$A$2:$A$7</c:f>
-              <c:multiLvlStrCache>
-                <c:ptCount val="6"/>
-                <c:lvl>
-                  <c:pt idx="0">
-                    <c:v>1ª</c:v>
-                  </c:pt>
-                  <c:pt idx="1">
-                    <c:v>2ª</c:v>
-                  </c:pt>
-                  <c:pt idx="2">
-                    <c:v>3ª</c:v>
-                  </c:pt>
-                  <c:pt idx="3">
-                    <c:v>4ª</c:v>
-                  </c:pt>
-                  <c:pt idx="4">
-                    <c:v>5ª</c:v>
-                  </c:pt>
-                  <c:pt idx="5">
-                    <c:v>6ª</c:v>
-                  </c:pt>
-                </c:lvl>
-              </c:multiLvlStrCache>
-            </c:multiLvlStrRef>
-          </c:cat>
-          <c:val>
-            <c:numRef>
-              <c:f>Sheet1!$B$2:$B$7</c:f>
-              <c:numCache>
-                <c:formatCode>General</c:formatCode>
-                <c:ptCount val="6"/>
-                <c:pt idx="0">
-                  <c:v>100</c:v>
-                </c:pt>
-                <c:pt idx="1">
-                  <c:v>80</c:v>
-                </c:pt>
-                <c:pt idx="2">
-                  <c:v>64</c:v>
-                </c:pt>
-                <c:pt idx="3">
-                  <c:v>51</c:v>
-                </c:pt>
-                <c:pt idx="4">
-                  <c:v>41</c:v>
-                </c:pt>
-                <c:pt idx="5">
-                  <c:v>33</c:v>
-                </c:pt>
-              </c:numCache>
-            </c:numRef>
-          </c:val>
-        </c:ser>
-        <c:dLbls>
-          <c:numFmt formatCode="0" sourceLinked="0"/>
-          <c:txPr>
-            <a:bodyPr/>
-            <a:lstStyle/>
-            <a:p>
-              <a:pPr>
-                <a:defRPr b="0" i="0" strike="noStrike" sz="1050" u="none">
-                  <a:solidFill>
-                    <a:srgbClr val="1F2A37"/>
-                  </a:solidFill>
-                  <a:latin typeface="Calibri"/>
-                </a:defRPr>
-              </a:pPr>
-            </a:p>
-          </c:txPr>
-          <c:showLegendKey val="0"/>
-          <c:showVal val="1"/>
-          <c:showCatName val="0"/>
-          <c:showSerName val="0"/>
-          <c:showPercent val="0"/>
-          <c:showBubbleSize val="0"/>
-          <c:showLeaderLines val="0"/>
-        </c:dLbls>
-        <c:gapWidth val="60"/>
-        <c:overlap val="0"/>
-        <c:axId val="2094734554"/>
-        <c:axId val="2094734552"/>
-        <c:axId val="2094734556"/>
-      </c:barChart>
-      <c:catAx>
-        <c:axId val="2094734554"/>
-        <c:scaling>
-          <c:orientation val="minMax"/>
-        </c:scaling>
-        <c:delete val="0"/>
-        <c:axPos val="b"/>
-        <c:numFmt formatCode="General" sourceLinked="1"/>
-        <c:majorTickMark val="out"/>
-        <c:minorTickMark val="none"/>
-        <c:tickLblPos val="low"/>
-        <c:spPr>
-          <a:ln w="12700" cap="flat">
-            <a:solidFill>
-              <a:srgbClr val="888888"/>
-            </a:solidFill>
-            <a:prstDash val="solid"/>
-            <a:round/>
-          </a:ln>
-        </c:spPr>
-        <c:txPr>
-          <a:bodyPr/>
-          <a:lstStyle/>
-          <a:p>
-            <a:pPr>
-              <a:defRPr sz="1100" b="0" i="0" u="none" strike="noStrike">
-                <a:solidFill>
-                  <a:srgbClr val="1F2A37"/>
-                </a:solidFill>
-                <a:latin typeface="Calibri"/>
-              </a:defRPr>
-            </a:pPr>
-            <a:endParaRPr lang="en-US"/>
-          </a:p>
-        </c:txPr>
-        <c:crossAx val="2094734552"/>
-        <c:crosses val="autoZero"/>
-        <c:auto val="1"/>
-        <c:lblAlgn val="ctr"/>
-        <c:noMultiLvlLbl val="1"/>
-      </c:catAx>
-      <c:valAx>
-        <c:axId val="2094734552"/>
-        <c:scaling>
-          <c:orientation val="minMax"/>
-          <c:max val="120"/>
-          <c:min val="0"/>
-        </c:scaling>
-        <c:delete val="0"/>
-        <c:axPos val="l"/>
-        <c:majorGridlines>
-          <c:spPr>
-            <a:ln w="6350" cap="flat">
-              <a:solidFill>
-                <a:srgbClr val="E3E3E3"/>
-              </a:solidFill>
-              <a:prstDash val="solid"/>
-              <a:round/>
-            </a:ln>
-          </c:spPr>
-        </c:majorGridlines>
-        <c:numFmt formatCode="0" sourceLinked="0"/>
-        <c:majorTickMark val="out"/>
-        <c:minorTickMark val="none"/>
-        <c:tickLblPos val="nextTo"/>
-        <c:spPr>
-          <a:ln w="12700" cap="flat">
-            <a:noFill/>
-            <a:prstDash val="solid"/>
-            <a:round/>
-          </a:ln>
-        </c:spPr>
-        <c:txPr>
-          <a:bodyPr/>
-          <a:lstStyle/>
-          <a:p>
-            <a:pPr>
-              <a:defRPr sz="1000" b="0" i="0" u="none" strike="noStrike">
-                <a:solidFill>
-                  <a:srgbClr val="5B6770"/>
-                </a:solidFill>
-                <a:latin typeface="Calibri"/>
-              </a:defRPr>
-            </a:pPr>
-            <a:endParaRPr lang="en-US"/>
-          </a:p>
-        </c:txPr>
-        <c:crossAx val="2094734554"/>
-        <c:crosses val="autoZero"/>
-        <c:crossBetween val="between"/>
-      </c:valAx>
-      <c:spPr>
-        <a:noFill/>
-        <a:ln>
-          <a:noFill/>
-        </a:ln>
-        <a:effectLst/>
-      </c:spPr>
-    </c:plotArea>
-    <c:plotVisOnly val="1"/>
-    <c:dispBlanksAs val="span"/>
-  </c:chart>
-  <c:spPr>
-    <a:noFill/>
-    <a:ln>
-      <a:noFill/>
-    </a:ln>
-    <a:effectLst/>
-  </c:spPr>
-  <c:externalData r:id="rId1">
-    <c:autoUpdate val="0"/>
-  </c:externalData>
-</c:chartSpace>
-</file>
-
-<file path=ppt/charts/chart7.xml><?xml version="1.0" encoding="utf-8"?>
-<c:chartSpace xmlns:c="http://schemas.openxmlformats.org/drawingml/2006/chart" xmlns:a="http://schemas.openxmlformats.org/drawingml/2006/main" xmlns:r="http://schemas.openxmlformats.org/officeDocument/2006/relationships">
-  <c:date1904 val="0"/>
-  <c:roundedCorners val="1"/>
-  <c:chart>
-    <c:autoTitleDeleted val="1"/>
-    <c:plotArea>
-      <c:layout/>
-      <c:barChart>
-        <c:barDir val="bar"/>
-        <c:grouping val="clustered"/>
-        <c:varyColors val="0"/>
-        <c:ser>
-          <c:idx val="0"/>
-          <c:order val="0"/>
-          <c:tx>
-            <c:strRef>
-              <c:f>Sheet1!$B$1</c:f>
-              <c:strCache>
-                <c:ptCount val="1"/>
-                <c:pt idx="0">
-                  <c:v>Gasto social</c:v>
-                </c:pt>
-              </c:strCache>
-            </c:strRef>
-          </c:tx>
-          <c:spPr>
-            <a:solidFill>
-              <a:srgbClr val="2A8C85"/>
-            </a:solidFill>
-            <a:effectLst/>
-          </c:spPr>
-          <c:invertIfNegative val="0"/>
-          <c:dLbls>
-            <c:numFmt formatCode="0.0" sourceLinked="0"/>
-            <c:txPr>
-              <a:bodyPr/>
-              <a:lstStyle/>
-              <a:p>
-                <a:pPr>
-                  <a:defRPr b="0" i="0" strike="noStrike" sz="1050" u="none">
-                    <a:solidFill>
-                      <a:srgbClr val="1F2A37"/>
-                    </a:solidFill>
-                    <a:latin typeface="Calibri"/>
-                  </a:defRPr>
-                </a:pPr>
-              </a:p>
-            </c:txPr>
-            <c:showLegendKey val="0"/>
-            <c:showVal val="1"/>
-            <c:showCatName val="0"/>
-            <c:showSerName val="0"/>
-            <c:showPercent val="0"/>
-            <c:showBubbleSize val="0"/>
-            <c:showLeaderLines val="0"/>
-          </c:dLbls>
-          <c:cat>
-            <c:multiLvlStrRef>
-              <c:f>Sheet1!$A$2:$A$5</c:f>
-              <c:multiLvlStrCache>
-                <c:ptCount val="4"/>
-                <c:lvl>
-                  <c:pt idx="0">
-                    <c:v>Alemanha (conservador)</c:v>
-                  </c:pt>
-                  <c:pt idx="1">
-                    <c:v>Suécia (social-democrata)</c:v>
-                  </c:pt>
-                  <c:pt idx="2">
-                    <c:v>Reino Unido (liberal)</c:v>
-                  </c:pt>
-                  <c:pt idx="3">
-                    <c:v>Estados Unidos (liberal)</c:v>
-                  </c:pt>
-                </c:lvl>
-              </c:multiLvlStrCache>
-            </c:multiLvlStrRef>
-          </c:cat>
-          <c:val>
-            <c:numRef>
-              <c:f>Sheet1!$B$2:$B$5</c:f>
-              <c:numCache>
-                <c:formatCode>General</c:formatCode>
-                <c:ptCount val="4"/>
-                <c:pt idx="0">
-                  <c:v>25.9</c:v>
-                </c:pt>
-                <c:pt idx="1">
-                  <c:v>25.5</c:v>
-                </c:pt>
-                <c:pt idx="2">
-                  <c:v>20.6</c:v>
-                </c:pt>
-                <c:pt idx="3">
-                  <c:v>18.7</c:v>
-                </c:pt>
-              </c:numCache>
-            </c:numRef>
-          </c:val>
-        </c:ser>
-        <c:dLbls>
-          <c:numFmt formatCode="0.0" sourceLinked="0"/>
-          <c:txPr>
-            <a:bodyPr/>
-            <a:lstStyle/>
-            <a:p>
-              <a:pPr>
-                <a:defRPr b="0" i="0" strike="noStrike" sz="1050" u="none">
-                  <a:solidFill>
-                    <a:srgbClr val="1F2A37"/>
-                  </a:solidFill>
-                  <a:latin typeface="Calibri"/>
-                </a:defRPr>
-              </a:pPr>
-            </a:p>
-          </c:txPr>
-          <c:showLegendKey val="0"/>
-          <c:showVal val="1"/>
-          <c:showCatName val="0"/>
-          <c:showSerName val="0"/>
-          <c:showPercent val="0"/>
-          <c:showBubbleSize val="0"/>
-          <c:showLeaderLines val="0"/>
-        </c:dLbls>
-        <c:gapWidth val="60"/>
-        <c:overlap val="0"/>
-        <c:axId val="2094734554"/>
-        <c:axId val="2094734552"/>
-        <c:axId val="2094734556"/>
-      </c:barChart>
-      <c:catAx>
-        <c:axId val="2094734554"/>
-        <c:scaling>
-          <c:orientation val="maxMin"/>
-        </c:scaling>
-        <c:delete val="0"/>
-        <c:axPos val="l"/>
-        <c:numFmt formatCode="General" sourceLinked="1"/>
-        <c:majorTickMark val="out"/>
-        <c:minorTickMark val="none"/>
-        <c:tickLblPos val="nextTo"/>
-        <c:spPr>
-          <a:ln w="12700" cap="flat">
-            <a:solidFill>
-              <a:srgbClr val="888888"/>
-            </a:solidFill>
-            <a:prstDash val="solid"/>
-            <a:round/>
-          </a:ln>
-        </c:spPr>
-        <c:txPr>
-          <a:bodyPr/>
-          <a:lstStyle/>
-          <a:p>
-            <a:pPr>
-              <a:defRPr sz="1100" b="0" i="0" u="none" strike="noStrike">
-                <a:solidFill>
-                  <a:srgbClr val="1F2A37"/>
-                </a:solidFill>
-                <a:latin typeface="Calibri"/>
-              </a:defRPr>
-            </a:pPr>
-            <a:endParaRPr lang="en-US"/>
-          </a:p>
-        </c:txPr>
-        <c:crossAx val="2094734552"/>
-        <c:crosses val="autoZero"/>
-        <c:auto val="1"/>
-        <c:lblAlgn val="ctr"/>
-        <c:noMultiLvlLbl val="1"/>
-      </c:catAx>
-      <c:valAx>
-        <c:axId val="2094734552"/>
-        <c:scaling>
-          <c:orientation val="minMax"/>
-          <c:max val="30"/>
-          <c:min val="0"/>
-        </c:scaling>
-        <c:delete val="0"/>
-        <c:axPos val="b"/>
-        <c:majorGridlines>
-          <c:spPr>
-            <a:ln w="6350" cap="flat">
-              <a:solidFill>
-                <a:srgbClr val="E3E3E3"/>
-              </a:solidFill>
-              <a:prstDash val="solid"/>
-              <a:round/>
-            </a:ln>
-          </c:spPr>
-        </c:majorGridlines>
-        <c:numFmt formatCode="0.0" sourceLinked="0"/>
-        <c:majorTickMark val="out"/>
-        <c:minorTickMark val="none"/>
-        <c:tickLblPos val="low"/>
-        <c:spPr>
-          <a:ln w="12700" cap="flat">
-            <a:noFill/>
-            <a:prstDash val="solid"/>
-            <a:round/>
-          </a:ln>
-        </c:spPr>
-        <c:txPr>
-          <a:bodyPr/>
-          <a:lstStyle/>
-          <a:p>
-            <a:pPr>
-              <a:defRPr sz="1000" b="0" i="0" u="none" strike="noStrike">
-                <a:solidFill>
-                  <a:srgbClr val="5B6770"/>
-                </a:solidFill>
-                <a:latin typeface="Calibri"/>
-              </a:defRPr>
-            </a:pPr>
-            <a:endParaRPr lang="en-US"/>
-          </a:p>
-        </c:txPr>
-        <c:crossAx val="2094734554"/>
-        <c:crosses val="autoZero"/>
-        <c:crossBetween val="between"/>
-      </c:valAx>
-      <c:spPr>
-        <a:noFill/>
-        <a:ln>
-          <a:noFill/>
-        </a:ln>
-        <a:effectLst/>
-      </c:spPr>
-    </c:plotArea>
-    <c:plotVisOnly val="1"/>
-    <c:dispBlanksAs val="span"/>
-  </c:chart>
-  <c:spPr>
-    <a:noFill/>
-    <a:ln>
-      <a:noFill/>
-    </a:ln>
-    <a:effectLst/>
-  </c:spPr>
-  <c:externalData r:id="rId1">
-    <c:autoUpdate val="0"/>
-  </c:externalData>
-</c:chartSpace>
-</file>
-
-<file path=ppt/charts/chart8.xml><?xml version="1.0" encoding="utf-8"?>
+<file path=ppt/charts/chart10.xml><?xml version="1.0" encoding="utf-8"?>
 <c:chartSpace xmlns:c="http://schemas.openxmlformats.org/drawingml/2006/chart" xmlns:a="http://schemas.openxmlformats.org/drawingml/2006/main" xmlns:r="http://schemas.openxmlformats.org/officeDocument/2006/relationships">
   <c:date1904 val="0"/>
   <c:roundedCorners val="1"/>
@@ -916,7 +412,7 @@
 </c:chartSpace>
 </file>
 
-<file path=ppt/charts/chart9.xml><?xml version="1.0" encoding="utf-8"?>
+<file path=ppt/charts/chart11.xml><?xml version="1.0" encoding="utf-8"?>
 <c:chartSpace xmlns:c="http://schemas.openxmlformats.org/drawingml/2006/chart" xmlns:a="http://schemas.openxmlformats.org/drawingml/2006/main" xmlns:r="http://schemas.openxmlformats.org/officeDocument/2006/relationships">
   <c:date1904 val="0"/>
   <c:roundedCorners val="1"/>
@@ -1124,6 +620,510 @@
         <c:majorTickMark val="out"/>
         <c:minorTickMark val="none"/>
         <c:tickLblPos val="nextTo"/>
+        <c:spPr>
+          <a:ln w="12700" cap="flat">
+            <a:noFill/>
+            <a:prstDash val="solid"/>
+            <a:round/>
+          </a:ln>
+        </c:spPr>
+        <c:txPr>
+          <a:bodyPr/>
+          <a:lstStyle/>
+          <a:p>
+            <a:pPr>
+              <a:defRPr sz="1000" b="0" i="0" u="none" strike="noStrike">
+                <a:solidFill>
+                  <a:srgbClr val="5B6770"/>
+                </a:solidFill>
+                <a:latin typeface="Calibri"/>
+              </a:defRPr>
+            </a:pPr>
+            <a:endParaRPr lang="en-US"/>
+          </a:p>
+        </c:txPr>
+        <c:crossAx val="2094734554"/>
+        <c:crosses val="autoZero"/>
+        <c:crossBetween val="between"/>
+      </c:valAx>
+      <c:spPr>
+        <a:noFill/>
+        <a:ln>
+          <a:noFill/>
+        </a:ln>
+        <a:effectLst/>
+      </c:spPr>
+    </c:plotArea>
+    <c:plotVisOnly val="1"/>
+    <c:dispBlanksAs val="span"/>
+  </c:chart>
+  <c:spPr>
+    <a:noFill/>
+    <a:ln>
+      <a:noFill/>
+    </a:ln>
+    <a:effectLst/>
+  </c:spPr>
+  <c:externalData r:id="rId1">
+    <c:autoUpdate val="0"/>
+  </c:externalData>
+</c:chartSpace>
+</file>
+
+<file path=ppt/charts/chart8.xml><?xml version="1.0" encoding="utf-8"?>
+<c:chartSpace xmlns:c="http://schemas.openxmlformats.org/drawingml/2006/chart" xmlns:a="http://schemas.openxmlformats.org/drawingml/2006/main" xmlns:r="http://schemas.openxmlformats.org/officeDocument/2006/relationships">
+  <c:date1904 val="0"/>
+  <c:roundedCorners val="1"/>
+  <c:chart>
+    <c:autoTitleDeleted val="1"/>
+    <c:plotArea>
+      <c:layout/>
+      <c:barChart>
+        <c:barDir val="col"/>
+        <c:grouping val="clustered"/>
+        <c:varyColors val="0"/>
+        <c:ser>
+          <c:idx val="0"/>
+          <c:order val="0"/>
+          <c:tx>
+            <c:strRef>
+              <c:f>Sheet1!$B$1</c:f>
+              <c:strCache>
+                <c:ptCount val="1"/>
+                <c:pt idx="0">
+                  <c:v>Renda</c:v>
+                </c:pt>
+              </c:strCache>
+            </c:strRef>
+          </c:tx>
+          <c:spPr>
+            <a:solidFill>
+              <a:srgbClr val="13294B"/>
+            </a:solidFill>
+            <a:effectLst/>
+          </c:spPr>
+          <c:invertIfNegative val="0"/>
+          <c:dLbls>
+            <c:numFmt formatCode="0" sourceLinked="0"/>
+            <c:txPr>
+              <a:bodyPr/>
+              <a:lstStyle/>
+              <a:p>
+                <a:pPr>
+                  <a:defRPr b="0" i="0" strike="noStrike" sz="1050" u="none">
+                    <a:solidFill>
+                      <a:srgbClr val="1F2A37"/>
+                    </a:solidFill>
+                    <a:latin typeface="Calibri"/>
+                  </a:defRPr>
+                </a:pPr>
+              </a:p>
+            </c:txPr>
+            <c:showLegendKey val="0"/>
+            <c:showVal val="1"/>
+            <c:showCatName val="0"/>
+            <c:showSerName val="0"/>
+            <c:showPercent val="0"/>
+            <c:showBubbleSize val="0"/>
+            <c:showLeaderLines val="0"/>
+          </c:dLbls>
+          <c:cat>
+            <c:multiLvlStrRef>
+              <c:f>Sheet1!$A$2:$A$7</c:f>
+              <c:multiLvlStrCache>
+                <c:ptCount val="6"/>
+                <c:lvl>
+                  <c:pt idx="0">
+                    <c:v>1ª</c:v>
+                  </c:pt>
+                  <c:pt idx="1">
+                    <c:v>2ª</c:v>
+                  </c:pt>
+                  <c:pt idx="2">
+                    <c:v>3ª</c:v>
+                  </c:pt>
+                  <c:pt idx="3">
+                    <c:v>4ª</c:v>
+                  </c:pt>
+                  <c:pt idx="4">
+                    <c:v>5ª</c:v>
+                  </c:pt>
+                  <c:pt idx="5">
+                    <c:v>6ª</c:v>
+                  </c:pt>
+                </c:lvl>
+              </c:multiLvlStrCache>
+            </c:multiLvlStrRef>
+          </c:cat>
+          <c:val>
+            <c:numRef>
+              <c:f>Sheet1!$B$2:$B$7</c:f>
+              <c:numCache>
+                <c:formatCode>General</c:formatCode>
+                <c:ptCount val="6"/>
+                <c:pt idx="0">
+                  <c:v>100</c:v>
+                </c:pt>
+                <c:pt idx="1">
+                  <c:v>80</c:v>
+                </c:pt>
+                <c:pt idx="2">
+                  <c:v>64</c:v>
+                </c:pt>
+                <c:pt idx="3">
+                  <c:v>51</c:v>
+                </c:pt>
+                <c:pt idx="4">
+                  <c:v>41</c:v>
+                </c:pt>
+                <c:pt idx="5">
+                  <c:v>33</c:v>
+                </c:pt>
+              </c:numCache>
+            </c:numRef>
+          </c:val>
+        </c:ser>
+        <c:dLbls>
+          <c:numFmt formatCode="0" sourceLinked="0"/>
+          <c:txPr>
+            <a:bodyPr/>
+            <a:lstStyle/>
+            <a:p>
+              <a:pPr>
+                <a:defRPr b="0" i="0" strike="noStrike" sz="1050" u="none">
+                  <a:solidFill>
+                    <a:srgbClr val="1F2A37"/>
+                  </a:solidFill>
+                  <a:latin typeface="Calibri"/>
+                </a:defRPr>
+              </a:pPr>
+            </a:p>
+          </c:txPr>
+          <c:showLegendKey val="0"/>
+          <c:showVal val="1"/>
+          <c:showCatName val="0"/>
+          <c:showSerName val="0"/>
+          <c:showPercent val="0"/>
+          <c:showBubbleSize val="0"/>
+          <c:showLeaderLines val="0"/>
+        </c:dLbls>
+        <c:gapWidth val="60"/>
+        <c:overlap val="0"/>
+        <c:axId val="2094734554"/>
+        <c:axId val="2094734552"/>
+        <c:axId val="2094734556"/>
+      </c:barChart>
+      <c:catAx>
+        <c:axId val="2094734554"/>
+        <c:scaling>
+          <c:orientation val="minMax"/>
+        </c:scaling>
+        <c:delete val="0"/>
+        <c:axPos val="b"/>
+        <c:numFmt formatCode="General" sourceLinked="1"/>
+        <c:majorTickMark val="out"/>
+        <c:minorTickMark val="none"/>
+        <c:tickLblPos val="low"/>
+        <c:spPr>
+          <a:ln w="12700" cap="flat">
+            <a:solidFill>
+              <a:srgbClr val="888888"/>
+            </a:solidFill>
+            <a:prstDash val="solid"/>
+            <a:round/>
+          </a:ln>
+        </c:spPr>
+        <c:txPr>
+          <a:bodyPr/>
+          <a:lstStyle/>
+          <a:p>
+            <a:pPr>
+              <a:defRPr sz="1100" b="0" i="0" u="none" strike="noStrike">
+                <a:solidFill>
+                  <a:srgbClr val="1F2A37"/>
+                </a:solidFill>
+                <a:latin typeface="Calibri"/>
+              </a:defRPr>
+            </a:pPr>
+            <a:endParaRPr lang="en-US"/>
+          </a:p>
+        </c:txPr>
+        <c:crossAx val="2094734552"/>
+        <c:crosses val="autoZero"/>
+        <c:auto val="1"/>
+        <c:lblAlgn val="ctr"/>
+        <c:noMultiLvlLbl val="1"/>
+      </c:catAx>
+      <c:valAx>
+        <c:axId val="2094734552"/>
+        <c:scaling>
+          <c:orientation val="minMax"/>
+          <c:max val="120"/>
+          <c:min val="0"/>
+        </c:scaling>
+        <c:delete val="0"/>
+        <c:axPos val="l"/>
+        <c:majorGridlines>
+          <c:spPr>
+            <a:ln w="6350" cap="flat">
+              <a:solidFill>
+                <a:srgbClr val="E3E3E3"/>
+              </a:solidFill>
+              <a:prstDash val="solid"/>
+              <a:round/>
+            </a:ln>
+          </c:spPr>
+        </c:majorGridlines>
+        <c:numFmt formatCode="0" sourceLinked="0"/>
+        <c:majorTickMark val="out"/>
+        <c:minorTickMark val="none"/>
+        <c:tickLblPos val="nextTo"/>
+        <c:spPr>
+          <a:ln w="12700" cap="flat">
+            <a:noFill/>
+            <a:prstDash val="solid"/>
+            <a:round/>
+          </a:ln>
+        </c:spPr>
+        <c:txPr>
+          <a:bodyPr/>
+          <a:lstStyle/>
+          <a:p>
+            <a:pPr>
+              <a:defRPr sz="1000" b="0" i="0" u="none" strike="noStrike">
+                <a:solidFill>
+                  <a:srgbClr val="5B6770"/>
+                </a:solidFill>
+                <a:latin typeface="Calibri"/>
+              </a:defRPr>
+            </a:pPr>
+            <a:endParaRPr lang="en-US"/>
+          </a:p>
+        </c:txPr>
+        <c:crossAx val="2094734554"/>
+        <c:crosses val="autoZero"/>
+        <c:crossBetween val="between"/>
+      </c:valAx>
+      <c:spPr>
+        <a:noFill/>
+        <a:ln>
+          <a:noFill/>
+        </a:ln>
+        <a:effectLst/>
+      </c:spPr>
+    </c:plotArea>
+    <c:plotVisOnly val="1"/>
+    <c:dispBlanksAs val="span"/>
+  </c:chart>
+  <c:spPr>
+    <a:noFill/>
+    <a:ln>
+      <a:noFill/>
+    </a:ln>
+    <a:effectLst/>
+  </c:spPr>
+  <c:externalData r:id="rId1">
+    <c:autoUpdate val="0"/>
+  </c:externalData>
+</c:chartSpace>
+</file>
+
+<file path=ppt/charts/chart9.xml><?xml version="1.0" encoding="utf-8"?>
+<c:chartSpace xmlns:c="http://schemas.openxmlformats.org/drawingml/2006/chart" xmlns:a="http://schemas.openxmlformats.org/drawingml/2006/main" xmlns:r="http://schemas.openxmlformats.org/officeDocument/2006/relationships">
+  <c:date1904 val="0"/>
+  <c:roundedCorners val="1"/>
+  <c:chart>
+    <c:autoTitleDeleted val="1"/>
+    <c:plotArea>
+      <c:layout/>
+      <c:barChart>
+        <c:barDir val="bar"/>
+        <c:grouping val="clustered"/>
+        <c:varyColors val="0"/>
+        <c:ser>
+          <c:idx val="0"/>
+          <c:order val="0"/>
+          <c:tx>
+            <c:strRef>
+              <c:f>Sheet1!$B$1</c:f>
+              <c:strCache>
+                <c:ptCount val="1"/>
+                <c:pt idx="0">
+                  <c:v>Gasto social</c:v>
+                </c:pt>
+              </c:strCache>
+            </c:strRef>
+          </c:tx>
+          <c:spPr>
+            <a:solidFill>
+              <a:srgbClr val="2A8C85"/>
+            </a:solidFill>
+            <a:effectLst/>
+          </c:spPr>
+          <c:invertIfNegative val="0"/>
+          <c:dLbls>
+            <c:numFmt formatCode="0.0" sourceLinked="0"/>
+            <c:txPr>
+              <a:bodyPr/>
+              <a:lstStyle/>
+              <a:p>
+                <a:pPr>
+                  <a:defRPr b="0" i="0" strike="noStrike" sz="1050" u="none">
+                    <a:solidFill>
+                      <a:srgbClr val="1F2A37"/>
+                    </a:solidFill>
+                    <a:latin typeface="Calibri"/>
+                  </a:defRPr>
+                </a:pPr>
+              </a:p>
+            </c:txPr>
+            <c:showLegendKey val="0"/>
+            <c:showVal val="1"/>
+            <c:showCatName val="0"/>
+            <c:showSerName val="0"/>
+            <c:showPercent val="0"/>
+            <c:showBubbleSize val="0"/>
+            <c:showLeaderLines val="0"/>
+          </c:dLbls>
+          <c:cat>
+            <c:multiLvlStrRef>
+              <c:f>Sheet1!$A$2:$A$5</c:f>
+              <c:multiLvlStrCache>
+                <c:ptCount val="4"/>
+                <c:lvl>
+                  <c:pt idx="0">
+                    <c:v>Alemanha (conservador)</c:v>
+                  </c:pt>
+                  <c:pt idx="1">
+                    <c:v>Suécia (social-democrata)</c:v>
+                  </c:pt>
+                  <c:pt idx="2">
+                    <c:v>Reino Unido (liberal)</c:v>
+                  </c:pt>
+                  <c:pt idx="3">
+                    <c:v>Estados Unidos (liberal)</c:v>
+                  </c:pt>
+                </c:lvl>
+              </c:multiLvlStrCache>
+            </c:multiLvlStrRef>
+          </c:cat>
+          <c:val>
+            <c:numRef>
+              <c:f>Sheet1!$B$2:$B$5</c:f>
+              <c:numCache>
+                <c:formatCode>General</c:formatCode>
+                <c:ptCount val="4"/>
+                <c:pt idx="0">
+                  <c:v>25.9</c:v>
+                </c:pt>
+                <c:pt idx="1">
+                  <c:v>25.5</c:v>
+                </c:pt>
+                <c:pt idx="2">
+                  <c:v>20.6</c:v>
+                </c:pt>
+                <c:pt idx="3">
+                  <c:v>18.7</c:v>
+                </c:pt>
+              </c:numCache>
+            </c:numRef>
+          </c:val>
+        </c:ser>
+        <c:dLbls>
+          <c:numFmt formatCode="0.0" sourceLinked="0"/>
+          <c:txPr>
+            <a:bodyPr/>
+            <a:lstStyle/>
+            <a:p>
+              <a:pPr>
+                <a:defRPr b="0" i="0" strike="noStrike" sz="1050" u="none">
+                  <a:solidFill>
+                    <a:srgbClr val="1F2A37"/>
+                  </a:solidFill>
+                  <a:latin typeface="Calibri"/>
+                </a:defRPr>
+              </a:pPr>
+            </a:p>
+          </c:txPr>
+          <c:showLegendKey val="0"/>
+          <c:showVal val="1"/>
+          <c:showCatName val="0"/>
+          <c:showSerName val="0"/>
+          <c:showPercent val="0"/>
+          <c:showBubbleSize val="0"/>
+          <c:showLeaderLines val="0"/>
+        </c:dLbls>
+        <c:gapWidth val="60"/>
+        <c:overlap val="0"/>
+        <c:axId val="2094734554"/>
+        <c:axId val="2094734552"/>
+        <c:axId val="2094734556"/>
+      </c:barChart>
+      <c:catAx>
+        <c:axId val="2094734554"/>
+        <c:scaling>
+          <c:orientation val="maxMin"/>
+        </c:scaling>
+        <c:delete val="0"/>
+        <c:axPos val="l"/>
+        <c:numFmt formatCode="General" sourceLinked="1"/>
+        <c:majorTickMark val="out"/>
+        <c:minorTickMark val="none"/>
+        <c:tickLblPos val="nextTo"/>
+        <c:spPr>
+          <a:ln w="12700" cap="flat">
+            <a:solidFill>
+              <a:srgbClr val="888888"/>
+            </a:solidFill>
+            <a:prstDash val="solid"/>
+            <a:round/>
+          </a:ln>
+        </c:spPr>
+        <c:txPr>
+          <a:bodyPr/>
+          <a:lstStyle/>
+          <a:p>
+            <a:pPr>
+              <a:defRPr sz="1100" b="0" i="0" u="none" strike="noStrike">
+                <a:solidFill>
+                  <a:srgbClr val="1F2A37"/>
+                </a:solidFill>
+                <a:latin typeface="Calibri"/>
+              </a:defRPr>
+            </a:pPr>
+            <a:endParaRPr lang="en-US"/>
+          </a:p>
+        </c:txPr>
+        <c:crossAx val="2094734552"/>
+        <c:crosses val="autoZero"/>
+        <c:auto val="1"/>
+        <c:lblAlgn val="ctr"/>
+        <c:noMultiLvlLbl val="1"/>
+      </c:catAx>
+      <c:valAx>
+        <c:axId val="2094734552"/>
+        <c:scaling>
+          <c:orientation val="minMax"/>
+          <c:max val="30"/>
+          <c:min val="0"/>
+        </c:scaling>
+        <c:delete val="0"/>
+        <c:axPos val="b"/>
+        <c:majorGridlines>
+          <c:spPr>
+            <a:ln w="6350" cap="flat">
+              <a:solidFill>
+                <a:srgbClr val="E3E3E3"/>
+              </a:solidFill>
+              <a:prstDash val="solid"/>
+              <a:round/>
+            </a:ln>
+          </c:spPr>
+        </c:majorGridlines>
+        <c:numFmt formatCode="0.0" sourceLinked="0"/>
+        <c:majorTickMark val="out"/>
+        <c:minorTickMark val="none"/>
+        <c:tickLblPos val="low"/>
         <c:spPr>
           <a:ln w="12700" cap="flat">
             <a:noFill/>

</xml_diff>